<commit_message>
Jury speaker notes (10 min) in markdown and in the deck's presenter view, with Q&A sheet
Co-Authored-By: Claude Opus 5.5 <noreply@anthropic.com>
Claude-Session: https://claude.ai/code/session_01TceV3SW8zHDtYbysNyQAPx
</commit_message>
<xml_diff>
--- a/submission/Agentic-GraphRAG-Application-Walkthrough.pptx
+++ b/submission/Agentic-GraphRAG-Application-Walkthrough.pptx
@@ -1058,10 +1058,23 @@
           <a:lstStyle/>
           <a:p>
             <a:r>
-              <a:rPr lang="en-US" dirty="0"/>
-              <a:t>Open with the question, not the technology: is an agent worth what it costs? Our answer is measured per question type. On the 100 public questions the agentic pipeline scores 0.98 exact match against 0.59 for plain RAG, and spends 40% of RAG's median tokens. It was right on 39 questions RAG got wrong and wrong on none RAG got right. Everything on these slides is the running application or its run files.</a:t>
-            </a:r>
-            <a:endParaRPr lang="en-US" dirty="0"/>
+              <a:t>[0:30 · clock 0:30]</a:t>
+            </a:r>
+          </a:p>
+          <a:p>
+            <a:r>
+              <a:t>• Question: when is an AI agent worth its tokens?</a:t>
+            </a:r>
+          </a:p>
+          <a:p>
+            <a:r>
+              <a:t>• Answer is measured, per question type, on 100 public questions.</a:t>
+            </a:r>
+          </a:p>
+          <a:p>
+            <a:r>
+              <a:t>• 0.98 Agentic EM vs 0.59 RAG · 0.40× RAG's median tokens · 39 wins / 0 losses vs RAG.</a:t>
+            </a:r>
           </a:p>
         </p:txBody>
       </p:sp>
@@ -1146,10 +1159,43 @@
           <a:lstStyle/>
           <a:p>
             <a:r>
-              <a:rPr lang="en-US" dirty="0"/>
-              <a:t>The dashboard answers the guidebook's question directly: for each question type, the accuracy gap over RAG and its token cost, with a verdict. The bottom row shows the routing in practice: 62 of 100 questions ended on the direct route, and 21 runs changed strategy.</a:t>
-            </a:r>
-            <a:endParaRPr lang="en-US" dirty="0"/>
+              <a:t>[0:40 · clock 5:20]</a:t>
+            </a:r>
+          </a:p>
+          <a:p>
+            <a:r>
+              <a:t>• Headline: Agentic EM 0.98 / F1 0.99 · GraphRAG 0.63 · RAG 0.59 / 0.65.</a:t>
+            </a:r>
+          </a:p>
+          <a:p>
+            <a:r>
+              <a:t>• Median tokens: Agentic 2,551 · GraphRAG 2,523 · RAG 6,453.</a:t>
+            </a:r>
+          </a:p>
+          <a:p>
+            <a:r>
+              <a:t>• Verdict per type:</a:t>
+            </a:r>
+          </a:p>
+          <a:p>
+            <a:r>
+              <a:t>    – Aggregation: +0.86 at 0.30× → worth it.</a:t>
+            </a:r>
+          </a:p>
+          <a:p>
+            <a:r>
+              <a:t>    – Superlative: +0.90 at 0.94× → worth it.</a:t>
+            </a:r>
+          </a:p>
+          <a:p>
+            <a:r>
+              <a:t>    – Lookup: 0.00 at 0.30× → overkill, but cheap.</a:t>
+            </a:r>
+          </a:p>
+          <a:p>
+            <a:r>
+              <a:t>• Routing: 62 direct · 35 sufficient evidence · 3 no further action. 21 runs changed strategy.</a:t>
+            </a:r>
           </a:p>
         </p:txBody>
       </p:sp>
@@ -1234,10 +1280,23 @@
           <a:lstStyle/>
           <a:p>
             <a:r>
-              <a:rPr lang="en-US" dirty="0"/>
-              <a:t>The matrix gives EM, F1, recall, precision and completeness per type and pipeline. The scatter plots every question by tokens and F1, so the cost of each answer is visible, not just the average.</a:t>
-            </a:r>
-            <a:endParaRPr lang="en-US" dirty="0"/>
+              <a:t>[0:25 · clock 5:45]</a:t>
+            </a:r>
+          </a:p>
+          <a:p>
+            <a:r>
+              <a:t>• Multi-hop: Agentic 0.96 vs GraphRAG 0.07 vs RAG 0.57. The loop, not the graph alone, is the gain.</a:t>
+            </a:r>
+          </a:p>
+          <a:p>
+            <a:r>
+              <a:t>• Temporal: Agentic 1.00 vs GraphRAG 0.59.</a:t>
+            </a:r>
+          </a:p>
+          <a:p>
+            <a:r>
+              <a:t>• Scatter: one point per question. Agentic clusters at F1 1.0 and low tokens.</a:t>
+            </a:r>
           </a:p>
         </p:txBody>
       </p:sp>
@@ -1322,10 +1381,43 @@
           <a:lstStyle/>
           <a:p>
             <a:r>
-              <a:rPr lang="en-US" dirty="0"/>
-              <a:t>Most agents are deterministic graph calls. Token spend concentrates in three LLM steps, which is why the agent is cheaper than RAG overall.</a:t>
-            </a:r>
-            <a:endParaRPr lang="en-US" dirty="0"/>
+              <a:t>[0:25 · clock 6:10]</a:t>
+            </a:r>
+          </a:p>
+          <a:p>
+            <a:r>
+              <a:t>• 0 errors in 300 answers.</a:t>
+            </a:r>
+          </a:p>
+          <a:p>
+            <a:r>
+              <a:t>• Grounded score needs no gold, so it also works on the hidden set: RAG 0.93 · Agentic 0.79 (count rows carry no prose).</a:t>
+            </a:r>
+          </a:p>
+          <a:p>
+            <a:r>
+              <a:t>• Only 3 agents call the LLM:</a:t>
+            </a:r>
+          </a:p>
+          <a:p>
+            <a:r>
+              <a:t>    – Orchestrator: 277k tokens.</a:t>
+            </a:r>
+          </a:p>
+          <a:p>
+            <a:r>
+              <a:t>    – Answer generation: 161k.</a:t>
+            </a:r>
+          </a:p>
+          <a:p>
+            <a:r>
+              <a:t>    – Evidence evaluation: 40k.</a:t>
+            </a:r>
+          </a:p>
+          <a:p>
+            <a:r>
+              <a:t>• Linking, traversal, aggregation and verification cost 0 tokens.</a:t>
+            </a:r>
           </a:p>
         </p:txBody>
       </p:sp>
@@ -1410,10 +1502,28 @@
           <a:lstStyle/>
           <a:p>
             <a:r>
-              <a:rPr lang="en-US" dirty="0"/>
-              <a:t>Each improvement came from a named root cause found in the traces, and RAG, which no fix touched, stayed flat at 0.59 to 0.62. That is how we know the gains are real and not tuning to the benchmark.</a:t>
-            </a:r>
-            <a:endParaRPr lang="en-US" dirty="0"/>
+              <a:t>[0:35 · clock 6:45]</a:t>
+            </a:r>
+          </a:p>
+          <a:p>
+            <a:r>
+              <a:t>• Every run is stored with its full config: model, embeddings, k, chunking, budgets.</a:t>
+            </a:r>
+          </a:p>
+          <a:p>
+            <a:r>
+              <a:t>• r1 → r5 for Agentic: EM 0.74 → 0.98, median tokens 4,700 → 2,551 (−46%).</a:t>
+            </a:r>
+          </a:p>
+          <a:p>
+            <a:r>
+              <a:t>• RAG flat at 0.59–0.62 throughout: the control. The gains are not noise.</a:t>
+            </a:r>
+          </a:p>
+          <a:p>
+            <a:r>
+              <a:t>• Export gives the submission JSON: answers, citations with snippets, full traces.</a:t>
+            </a:r>
           </a:p>
         </p:txBody>
       </p:sp>
@@ -1498,10 +1608,18 @@
           <a:lstStyle/>
           <a:p>
             <a:r>
-              <a:rPr lang="en-US" dirty="0"/>
-              <a:t>The eval table is where the research question lives: the disagreement filter shows exactly where the methods differ, question by question.</a:t>
-            </a:r>
-            <a:endParaRPr lang="en-US" dirty="0"/>
+              <a:t>[0:15 · clock 7:00]</a:t>
+            </a:r>
+          </a:p>
+          <a:p>
+            <a:r>
+              <a:t>• Per question: gold + all three pipelines (answer, EM, F1, P, R, tokens, latency).</a:t>
+            </a:r>
+          </a:p>
+          <a:p>
+            <a:r>
+              <a:t>• "Disagree only" filter: 66 of 100 questions. This is where the research question lives.</a:t>
+            </a:r>
           </a:p>
         </p:txBody>
       </p:sp>
@@ -1586,10 +1704,13 @@
           <a:lstStyle/>
           <a:p>
             <a:r>
-              <a:rPr lang="en-US" dirty="0"/>
-              <a:t>History is the audit log of the application. It records every attempt, including the ones that failed, so the evaluation team can see the system's real behaviour.</a:t>
-            </a:r>
-            <a:endParaRPr lang="en-US" dirty="0"/>
+              <a:t>[0:10 · clock 7:10]</a:t>
+            </a:r>
+          </a:p>
+          <a:p>
+            <a:r>
+              <a:t>• Audit log of every query, build and benchmark, including failed, partial and refused attempts.</a:t>
+            </a:r>
           </a:p>
         </p:txBody>
       </p:sp>
@@ -1674,10 +1795,38 @@
           <a:lstStyle/>
           <a:p>
             <a:r>
-              <a:rPr lang="en-US" dirty="0"/>
-              <a:t>Embedding switching is a guarded operation: per-model vertex types mean two 1024-dimension models are never treated as interchangeable, and a half-built index can never answer a query.</a:t>
-            </a:r>
-            <a:endParaRPr lang="en-US" dirty="0"/>
+              <a:t>[0:20 · clock 7:30]</a:t>
+            </a:r>
+          </a:p>
+          <a:p>
+            <a:r>
+              <a:t>• LLM provider/model switchable at runtime: NVIDIA NIM, Gemini, Groq. One model serves all three pipelines.</a:t>
+            </a:r>
+          </a:p>
+          <a:p>
+            <a:r>
+              <a:t>• Embeddings:</a:t>
+            </a:r>
+          </a:p>
+          <a:p>
+            <a:r>
+              <a:t>    – 5 models; each gets its own vertex type and HNSW index; at most 2 stored at once.</a:t>
+            </a:r>
+          </a:p>
+          <a:p>
+            <a:r>
+              <a:t>    – A query never searches another model's vectors. An incomplete model is refused.</a:t>
+            </a:r>
+          </a:p>
+          <a:p>
+            <a:r>
+              <a:t>• Re-embed runs in the background (replace or parallel) and resumes after failure.</a:t>
+            </a:r>
+          </a:p>
+          <a:p>
+            <a:r>
+              <a:t>## Results and close (7:30–9:20)</a:t>
+            </a:r>
           </a:p>
         </p:txBody>
       </p:sp>
@@ -1762,10 +1911,58 @@
           <a:lstStyle/>
           <a:p>
             <a:r>
-              <a:rPr lang="en-US" dirty="0"/>
-              <a:t>The agent leads where structure matters (aggregation, superlatives, multi-hop) and ties RAG on single facts and dates. It is not always better; it pays where it should and costs less where the router skips the loop. The hidden set (50 questions) was run once; it has no gold answers, so we report cost and grounding for it.</a:t>
-            </a:r>
-            <a:endParaRPr lang="en-US" dirty="0"/>
+              <a:t>[0:35 · clock 8:05]</a:t>
+            </a:r>
+          </a:p>
+          <a:p>
+            <a:r>
+              <a:t>• EM per type (RAG / GraphRAG / Agentic):</a:t>
+            </a:r>
+          </a:p>
+          <a:p>
+            <a:r>
+              <a:t>   Type · RAG · GraphRAG · Agentic</a:t>
+            </a:r>
+          </a:p>
+          <a:p>
+            <a:r>
+              <a:t>   Lookup · 1.00 · 0.95 · 1.00</a:t>
+            </a:r>
+          </a:p>
+          <a:p>
+            <a:r>
+              <a:t>   Multi-hop · 0.57 · 0.07 · 0.96</a:t>
+            </a:r>
+          </a:p>
+          <a:p>
+            <a:r>
+              <a:t>   Temporal · 0.95 · 0.59 · 1.00</a:t>
+            </a:r>
+          </a:p>
+          <a:p>
+            <a:r>
+              <a:t>   Aggregation · 0.14 · 1.00 · 1.00</a:t>
+            </a:r>
+          </a:p>
+          <a:p>
+            <a:r>
+              <a:t>   Superlative · 0.00 · 0.90 · 0.90</a:t>
+            </a:r>
+          </a:p>
+          <a:p>
+            <a:r>
+              <a:t>• Direct route: 62 questions · median 1,924 tokens · EM 1.00.</a:t>
+            </a:r>
+          </a:p>
+          <a:p>
+            <a:r>
+              <a:t>• Loop: 38 questions · median 7,416 tokens · EM 0.95.</a:t>
+            </a:r>
+          </a:p>
+          <a:p>
+            <a:r>
+              <a:t>• Routing saved ≈ 277k tokens vs sending everything through the loop (estimate).</a:t>
+            </a:r>
           </a:p>
         </p:txBody>
       </p:sp>
@@ -1850,10 +2047,43 @@
           <a:lstStyle/>
           <a:p>
             <a:r>
-              <a:rPr lang="en-US" dirty="0"/>
-              <a:t>A few points to land: every run file carries its configuration, so a result is never separated from its conditions. Runs resume question by question. And a test fails if anyone reads the question type or adds a question template in the answer path.</a:t>
-            </a:r>
-            <a:endParaRPr lang="en-US" dirty="0"/>
+              <a:t>[0:30 · clock 8:35]</a:t>
+            </a:r>
+          </a:p>
+          <a:p>
+            <a:r>
+              <a:t>• Reproducible: make reproduce (build → public + hidden runs → report → export). Run config in every file.</a:t>
+            </a:r>
+          </a:p>
+          <a:p>
+            <a:r>
+              <a:t>• Reliable:</a:t>
+            </a:r>
+          </a:p>
+          <a:p>
+            <a:r>
+              <a:t>    – Resumable batches.</a:t>
+            </a:r>
+          </a:p>
+          <a:p>
+            <a:r>
+              <a:t>    – Graph/LLM transients are retried and recorded, never silently degraded.</a:t>
+            </a:r>
+          </a:p>
+          <a:p>
+            <a:r>
+              <a:t>    – A fresh install adopts an existing graph.</a:t>
+            </a:r>
+          </a:p>
+          <a:p>
+            <a:r>
+              <a:t>• Not overfitted: no question templates and no question-type read in the answer path (enforced by tests). No prompt tuned on the benchmark.</a:t>
+            </a:r>
+          </a:p>
+          <a:p>
+            <a:r>
+              <a:t>• Tested: ~600 backend + 59 frontend tests; UI checked in a real browser.</a:t>
+            </a:r>
           </a:p>
         </p:txBody>
       </p:sp>
@@ -1938,10 +2168,58 @@
           <a:lstStyle/>
           <a:p>
             <a:r>
-              <a:rPr lang="en-US" dirty="0"/>
-              <a:t>Be honest here; judges respect it. The remaining weak spot is ambiguity, and the right behaviour there is to ask back instead of guessing.</a:t>
-            </a:r>
-            <a:endParaRPr lang="en-US" dirty="0"/>
+              <a:t>[0:25 · clock 9:00]</a:t>
+            </a:r>
+          </a:p>
+          <a:p>
+            <a:r>
+              <a:t>• Limits:</a:t>
+            </a:r>
+          </a:p>
+          <a:p>
+            <a:r>
+              <a:t>    – Intent-parse variance at temp 0 (the one open public miss).</a:t>
+            </a:r>
+          </a:p>
+          <a:p>
+            <a:r>
+              <a:t>    – Shared venue days with no sport named are ambiguous.</a:t>
+            </a:r>
+          </a:p>
+          <a:p>
+            <a:r>
+              <a:t>    – Round 2 has only its first step: infobox-vs-prose conflict flags.</a:t>
+            </a:r>
+          </a:p>
+          <a:p>
+            <a:r>
+              <a:t>    – The app is open (no auth).</a:t>
+            </a:r>
+          </a:p>
+          <a:p>
+            <a:r>
+              <a:t>• Next:</a:t>
+            </a:r>
+          </a:p>
+          <a:p>
+            <a:r>
+              <a:t>    – Ask back on ambiguity.</a:t>
+            </a:r>
+          </a:p>
+          <a:p>
+            <a:r>
+              <a:t>    – Second intent parse when operation and anchors disagree.</a:t>
+            </a:r>
+          </a:p>
+          <a:p>
+            <a:r>
+              <a:t>    – Versioned facts with source authority.</a:t>
+            </a:r>
+          </a:p>
+          <a:p>
+            <a:r>
+              <a:t>    – Auth at a proxy.</a:t>
+            </a:r>
           </a:p>
         </p:txBody>
       </p:sp>
@@ -2026,10 +2304,68 @@
           <a:lstStyle/>
           <a:p>
             <a:r>
-              <a:rPr lang="en-US" dirty="0"/>
-              <a:t>This is an ablation. RAG removes the graph, GraphRAG removes the loop, Agentic has both. Because the LLM, prompt, scorer and graph are shared, any difference in accuracy or cost comes from the method alone.</a:t>
-            </a:r>
-            <a:endParaRPr lang="en-US" dirty="0"/>
+              <a:t>[0:40 · clock 1:10]</a:t>
+            </a:r>
+          </a:p>
+          <a:p>
+            <a:r>
+              <a:t>• Pipelines:</a:t>
+            </a:r>
+          </a:p>
+          <a:p>
+            <a:r>
+              <a:t>    – RAG: Q5 vector top-10 over 16,669 chunks. No graph, no loop.</a:t>
+            </a:r>
+          </a:p>
+          <a:p>
+            <a:r>
+              <a:t>    – GraphRAG: shared intent parser + exactly 1 graph query (Q1–Q4). Graph, no loop.</a:t>
+            </a:r>
+          </a:p>
+          <a:p>
+            <a:r>
+              <a:t>    – Agentic: intent → link → route → graph tools → evidence check → re-query → verify.</a:t>
+            </a:r>
+          </a:p>
+          <a:p>
+            <a:r>
+              <a:t>• It's an ablation:</a:t>
+            </a:r>
+          </a:p>
+          <a:p>
+            <a:r>
+              <a:t>    – GraphRAG − RAG = value of the graph.</a:t>
+            </a:r>
+          </a:p>
+          <a:p>
+            <a:r>
+              <a:t>    – Agentic − GraphRAG = value of the loop.</a:t>
+            </a:r>
+          </a:p>
+          <a:p>
+            <a:r>
+              <a:t>• Held constant across all three:</a:t>
+            </a:r>
+          </a:p>
+          <a:p>
+            <a:r>
+              <a:t>    – LLM nvidia/nemotron-3-super-120b-a12b, temp 0.</a:t>
+            </a:r>
+          </a:p>
+          <a:p>
+            <a:r>
+              <a:t>    – Byte-identical answer prompt and the same deterministic scorer.</a:t>
+            </a:r>
+          </a:p>
+          <a:p>
+            <a:r>
+              <a:t>    – Same graph, same embeddings (bge-large-en-v1.5, 1024-d).</a:t>
+            </a:r>
+          </a:p>
+          <a:p>
+            <a:r>
+              <a:t>• Every graph-side fix also went to GraphRAG.</a:t>
+            </a:r>
           </a:p>
         </p:txBody>
       </p:sp>
@@ -2114,10 +2450,154 @@
           <a:lstStyle/>
           <a:p>
             <a:r>
-              <a:rPr lang="en-US" dirty="0"/>
-              <a:t>Close on the thesis in one sentence, then take questions. Likely questions: Is the comparison fair? Same LLM, same prompt byte for byte, same scorer; GraphRAG gets every graph fix too. Did you tune on the public set? No prompt was tuned; RAG, which no fix touched, stayed at 0.59 to 0.62. Why is the agent's grounding lower than RAG's? Count answers cite a count row with no prose; verification reports graph support separately (90 of 100). Hidden set? Run once; outputs in submission/; no gold, so cost and grounding only.</a:t>
-            </a:r>
-            <a:endParaRPr lang="en-US" dirty="0"/>
+              <a:t>[0:20 · clock 9:20]</a:t>
+            </a:r>
+          </a:p>
+          <a:p>
+            <a:r>
+              <a:t>• The agent is not always better. It pays where structure matters: counts, superlatives, multi-hop.</a:t>
+            </a:r>
+          </a:p>
+          <a:p>
+            <a:r>
+              <a:t>• And it costs less overall: 0.98 EM at 40% of RAG's tokens.</a:t>
+            </a:r>
+          </a:p>
+          <a:p>
+            <a:r>
+              <a:t>• Invite questions.</a:t>
+            </a:r>
+          </a:p>
+          <a:p>
+            <a:r>
+              <a:t>---</a:t>
+            </a:r>
+          </a:p>
+          <a:p/>
+          <a:p>
+            <a:r>
+              <a:t>Q&amp;A</a:t>
+            </a:r>
+          </a:p>
+          <a:p>
+            <a:r>
+              <a:t>Q: Is the comparison fair?</a:t>
+            </a:r>
+          </a:p>
+          <a:p>
+            <a:r>
+              <a:t>A: Same LLM, temp 0, byte-identical answer prompt, same scorer, same graph and embeddings. GraphRAG gets every graph fix. Only the method differs.</a:t>
+            </a:r>
+          </a:p>
+          <a:p>
+            <a:r>
+              <a:t>Q: Did you tune on the public set?</a:t>
+            </a:r>
+          </a:p>
+          <a:p>
+            <a:r>
+              <a:t>A: No prompt tuned. Each gain fixed a named root cause found in traces. RAG (untouched) stayed 0.59–0.62 across r1–r5. Tests block templates and question-type reads.</a:t>
+            </a:r>
+          </a:p>
+          <a:p>
+            <a:r>
+              <a:t>Q: Why is Agentic grounding (0.79) below RAG (0.93)?</a:t>
+            </a:r>
+          </a:p>
+          <a:p>
+            <a:r>
+              <a:t>A: Grounding = answer names found in the cited text. Count answers cite count rows with no prose. Separate graph-support check: 90/100 answers supported.</a:t>
+            </a:r>
+          </a:p>
+          <a:p>
+            <a:r>
+              <a:t>Q: Why is GraphRAG worse than RAG on temporal/multi-hop?</a:t>
+            </a:r>
+          </a:p>
+          <a:p>
+            <a:r>
+              <a:t>A: One query, no loop: cannot chain hops or recover from a weak first query. That gap is the loop's value.</a:t>
+            </a:r>
+          </a:p>
+          <a:p>
+            <a:r>
+              <a:t>Q: Why is the agent cheaper than RAG?</a:t>
+            </a:r>
+          </a:p>
+          <a:p>
+            <a:r>
+              <a:t>A: 62% of questions take the direct route (median 1,924 tokens). RAG always sends 10 chunks (~6.5k tokens).</a:t>
+            </a:r>
+          </a:p>
+          <a:p>
+            <a:r>
+              <a:t>Q: When is the agent not worth it?</a:t>
+            </a:r>
+          </a:p>
+          <a:p>
+            <a:r>
+              <a:t>A: Single-fact lookups and dates: RAG is already exact. The router keeps those cheap (0.30× tokens).</a:t>
+            </a:r>
+          </a:p>
+          <a:p>
+            <a:r>
+              <a:t>Q: What did the agent get wrong?</a:t>
+            </a:r>
+          </a:p>
+          <a:p>
+            <a:r>
+              <a:t>A: 2/100 in r5. pub-067: venue parsed into the event slot (fixed after r5, verified live). pub-088: model copied an evidence field (answer now cleaned; residual is intent-parse variance).</a:t>
+            </a:r>
+          </a:p>
+          <a:p>
+            <a:r>
+              <a:t>Q: Hidden set?</a:t>
+            </a:r>
+          </a:p>
+          <a:p>
+            <a:r>
+              <a:t>A: 50 questions, run once, 0 errors in 150 answers. Raw outputs and traces in submission/. No gold, so cost/routing/grounding only. Produced by the pre-final-round system (decision recorded).</a:t>
+            </a:r>
+          </a:p>
+          <a:p>
+            <a:r>
+              <a:t>Q: How do you handle LLM/graph failures?</a:t>
+            </a:r>
+          </a:p>
+          <a:p>
+            <a:r>
+              <a:t>A: Retries with backoff. Failures recorded on the trace step and as errors; a resumed batch re-runs only failed questions. Never turned into "no evidence".</a:t>
+            </a:r>
+          </a:p>
+          <a:p>
+            <a:r>
+              <a:t>Q: Why TigerGraph?</a:t>
+            </a:r>
+          </a:p>
+          <a:p>
+            <a:r>
+              <a:t>A: Typed multi-hop traversal (venue → event → edition) plus native vector search (HNSW) in one store. Installed GSQL queries Q1–Q5 keep tool calls deterministic and 0-token.</a:t>
+            </a:r>
+          </a:p>
+          <a:p>
+            <a:r>
+              <a:t>Q: How does it scale to new data?</a:t>
+            </a:r>
+          </a:p>
+          <a:p>
+            <a:r>
+              <a:t>A: Upload any JSONL corpus. Datasets are tracked per id, rebuilt independently. Embedding models switch per graph.</a:t>
+            </a:r>
+          </a:p>
+          <a:p>
+            <a:r>
+              <a:t>Q: Round 2 readiness?</a:t>
+            </a:r>
+          </a:p>
+          <a:p>
+            <a:r>
+              <a:t>A: First step done: answer verification flags infobox-vs-prose figure conflicts. Next: versioned facts, supersession, source authority.</a:t>
+            </a:r>
           </a:p>
         </p:txBody>
       </p:sp>
@@ -2202,10 +2682,68 @@
           <a:lstStyle/>
           <a:p>
             <a:r>
-              <a:rPr lang="en-US" dirty="0"/>
-              <a:t>The agent is a LangGraph orchestrator over five installed GSQL queries: Q1 lookup, Q2 count-where, Q3 argmax, Q4 traversal, Q5 hybrid vector search. Entity linking costs no tokens: it matches the question against the graph's own vocabularies. The router decides from the parsed and linked question whether one query is enough. A fully specified lookup or count takes the direct route; anything else enters the investigation loop.</a:t>
-            </a:r>
-            <a:endParaRPr lang="en-US" dirty="0"/>
+              <a:t>[0:50 · clock 2:00]</a:t>
+            </a:r>
+          </a:p>
+          <a:p>
+            <a:r>
+              <a:t>• Six stages:</a:t>
+            </a:r>
+          </a:p>
+          <a:p>
+            <a:r>
+              <a:t>    – Intent parse: LLM tool call → operation, anchors, filters.</a:t>
+            </a:r>
+          </a:p>
+          <a:p>
+            <a:r>
+              <a:t>    – Entity linking: gazetteer over the graph's own vocabularies (21 Games, 42 sports, 319 venues). 0 tokens.</a:t>
+            </a:r>
+          </a:p>
+          <a:p>
+            <a:r>
+              <a:t>    – Necessity router: fully specified lookup/count → direct route (1 query). Anything else → investigation loop.</a:t>
+            </a:r>
+          </a:p>
+          <a:p>
+            <a:r>
+              <a:t>    – GSQL tools: Q1 lookup · Q2 count-where · Q3 argmax · Q4 traversal (HELD_AT, PREV/NEXT_EDITION) · Q5 hybrid vector.</a:t>
+            </a:r>
+          </a:p>
+          <a:p>
+            <a:r>
+              <a:t>    – Evidence check: LLM groundedness. On fail, change strategy (similarity search / document chunks).</a:t>
+            </a:r>
+          </a:p>
+          <a:p>
+            <a:r>
+              <a:t>    – Answer + verify: shared prompt. Answer checked against graph rows (support, page-title resolution, conflict flags).</a:t>
+            </a:r>
+          </a:p>
+          <a:p>
+            <a:r>
+              <a:t>• Graph:</a:t>
+            </a:r>
+          </a:p>
+          <a:p>
+            <a:r>
+              <a:t>    – 2,951 documents · 2,187 events · 16,669 chunks · 11,343 relationships.</a:t>
+            </a:r>
+          </a:p>
+          <a:p>
+            <a:r>
+              <a:t>    – Vertices: Document, OlympicEvent, Games, Sport, Venue, Chunk, plus one Embedding_* type per model.</a:t>
+            </a:r>
+          </a:p>
+          <a:p>
+            <a:r>
+              <a:t>• Loop limits: max 6 steps, 20k tokens per query.</a:t>
+            </a:r>
+          </a:p>
+          <a:p>
+            <a:r>
+              <a:t>## Application tour (2:00–6:30)</a:t>
+            </a:r>
           </a:p>
         </p:txBody>
       </p:sp>
@@ -2290,10 +2828,13 @@
           <a:lstStyle/>
           <a:p>
             <a:r>
-              <a:rPr lang="en-US" dirty="0"/>
-              <a:t>From here, each slide is one screen of the running application with what it shows and why it matters.</a:t>
-            </a:r>
-            <a:endParaRPr lang="en-US" dirty="0"/>
+              <a:t>[0:05 · clock 2:05]</a:t>
+            </a:r>
+          </a:p>
+          <a:p>
+            <a:r>
+              <a:t>• "Every screen shown is the running app on the live TigerGraph graph."</a:t>
+            </a:r>
           </a:p>
         </p:txBody>
       </p:sp>
@@ -2378,10 +2919,38 @@
           <a:lstStyle/>
           <a:p>
             <a:r>
-              <a:rPr lang="en-US" dirty="0"/>
-              <a:t>The Build screen loads a corpus into the shared graph and streams progress per pipeline. It shows when each pipeline can answer, not just a single progress bar. Building never calls an LLM, so it costs no tokens.</a:t>
-            </a:r>
-            <a:endParaRPr lang="en-US" dirty="0"/>
+              <a:t>[0:25 · clock 2:30]</a:t>
+            </a:r>
+          </a:p>
+          <a:p>
+            <a:r>
+              <a:t>• One shared ingestion with a readiness line per pipeline:</a:t>
+            </a:r>
+          </a:p>
+          <a:p>
+            <a:r>
+              <a:t>    – RAG needs chunks + vectors.</a:t>
+            </a:r>
+          </a:p>
+          <a:p>
+            <a:r>
+              <a:t>    – GraphRAG needs the graph.</a:t>
+            </a:r>
+          </a:p>
+          <a:p>
+            <a:r>
+              <a:t>    – Agentic needs both.</a:t>
+            </a:r>
+          </a:p>
+          <a:p>
+            <a:r>
+              <a:t>• Deterministic infobox parsing: 0 LLM tokens to build.</a:t>
+            </a:r>
+          </a:p>
+          <a:p>
+            <a:r>
+              <a:t>• Dataset tracking: a rebuild replaces only its own data. A fresh install adopts an existing graph from TigerGraph.</a:t>
+            </a:r>
           </a:p>
         </p:txBody>
       </p:sp>
@@ -2466,10 +3035,33 @@
           <a:lstStyle/>
           <a:p>
             <a:r>
-              <a:rPr lang="en-US" dirty="0"/>
-              <a:t>A count is where structure matters: RAG can only count what it happens to retrieve. Here it got lucky, but at 4.7 times the tokens. The agent's router sends a fully specified count straight to one graph query, so it is both exact and cheap.</a:t>
-            </a:r>
-            <a:endParaRPr lang="en-US" dirty="0"/>
+              <a:t>[0:35 · clock 3:05]</a:t>
+            </a:r>
+          </a:p>
+          <a:p>
+            <a:r>
+              <a:t>• Q: biathlon events, 2006 Winter, &gt; 72 competitors.</a:t>
+            </a:r>
+          </a:p>
+          <a:p>
+            <a:r>
+              <a:t>• All three answer 4.</a:t>
+            </a:r>
+          </a:p>
+          <a:p>
+            <a:r>
+              <a:t>• Tokens: RAG 8,532 (10 chunks) · GraphRAG 1,851 · Agentic 1,817 = 0.21× RAG.</a:t>
+            </a:r>
+          </a:p>
+          <a:p>
+            <a:r>
+              <a:t>• RAG can only count what it happens to retrieve. Here it was right, at 4.7× the cost.</a:t>
+            </a:r>
+          </a:p>
+          <a:p>
+            <a:r>
+              <a:t>• Agentic cites each counted event (Q2 returns its members).</a:t>
+            </a:r>
           </a:p>
         </p:txBody>
       </p:sp>
@@ -2554,10 +3146,23 @@
           <a:lstStyle/>
           <a:p>
             <a:r>
-              <a:rPr lang="en-US" dirty="0"/>
-              <a:t>Every agent step is recorded with its tool, tokens, latency, chunks and citations. The stop reason is explicit. A judge can see exactly why the answer is 4 and what it cost.</a:t>
-            </a:r>
-            <a:endParaRPr lang="en-US" dirty="0"/>
+              <a:t>[0:20 · clock 3:25]</a:t>
+            </a:r>
+          </a:p>
+          <a:p>
+            <a:r>
+              <a:t>• 5 steps: intent parse → entity linking (2006-Winter, Biathlon; 0 tokens) → Q2 count-where → answer → verification.</a:t>
+            </a:r>
+          </a:p>
+          <a:p>
+            <a:r>
+              <a:t>• Stop reason: direct_route. Plan deviated: no.</a:t>
+            </a:r>
+          </a:p>
+          <a:p>
+            <a:r>
+              <a:t>• Each step logs tool, tokens, latency, chunks and citations.</a:t>
+            </a:r>
           </a:p>
         </p:txBody>
       </p:sp>
@@ -2642,10 +3247,43 @@
           <a:lstStyle/>
           <a:p>
             <a:r>
-              <a:rPr lang="en-US" dirty="0"/>
-              <a:t>This is the case the agent exists for. The question names a venue and a day, not an event. RAG retrieves a plausible chunk and answers with the wrong event. GraphRAG runs one query and has nothing to chain. The agent finds the 37 events at the venue, narrows them to the one on 16 August, and answers Valerie Vili, at roughly the same token cost as RAG.</a:t>
-            </a:r>
-            <a:endParaRPr lang="en-US" dirty="0"/>
+              <a:t>[0:40 · clock 4:05]</a:t>
+            </a:r>
+          </a:p>
+          <a:p>
+            <a:r>
+              <a:t>• Q: gold medallist, event at Beijing National Stadium on 16 Aug 2008.</a:t>
+            </a:r>
+          </a:p>
+          <a:p>
+            <a:r>
+              <a:t>• Names a venue and a day, not an event.</a:t>
+            </a:r>
+          </a:p>
+          <a:p>
+            <a:r>
+              <a:t>• Answers:</a:t>
+            </a:r>
+          </a:p>
+          <a:p>
+            <a:r>
+              <a:t>    – RAG: Usain Bolt. Wrong: same stadium, wrong event.</a:t>
+            </a:r>
+          </a:p>
+          <a:p>
+            <a:r>
+              <a:t>    – GraphRAG: "Not in context". One query cannot chain venue → day → winner.</a:t>
+            </a:r>
+          </a:p>
+          <a:p>
+            <a:r>
+              <a:t>    – Agentic: Valerie Vili (women's shot put). Correct.</a:t>
+            </a:r>
+          </a:p>
+          <a:p>
+            <a:r>
+              <a:t>• Agentic cost ≈ RAG (1.00×): correct at no extra cost.</a:t>
+            </a:r>
           </a:p>
         </p:txBody>
       </p:sp>
@@ -2730,10 +3368,33 @@
           <a:lstStyle/>
           <a:p>
             <a:r>
-              <a:rPr lang="en-US" dirty="0"/>
-              <a:t>The highlighted step is a strategy change: the agent judged its evidence insufficient and went to the document text. The trace makes the agent's reasoning auditable, which is what the evidence and explainability criterion asks for.</a:t>
-            </a:r>
-            <a:endParaRPr lang="en-US" dirty="0"/>
+              <a:t>[0:35 · clock 4:40]</a:t>
+            </a:r>
+          </a:p>
+          <a:p>
+            <a:r>
+              <a:t>• Step 3: Q4 HELD_AT → Q1. 37 events at the venue, narrowed to 1 by date.</a:t>
+            </a:r>
+          </a:p>
+          <a:p>
+            <a:r>
+              <a:t>• Step 4: groundedness fails on the row alone.</a:t>
+            </a:r>
+          </a:p>
+          <a:p>
+            <a:r>
+              <a:t>• Step 5 (highlighted): strategy change, fetches the event page text (HAS_CHUNK).</a:t>
+            </a:r>
+          </a:p>
+          <a:p>
+            <a:r>
+              <a:t>• Step 7: evidence passes. Step 9: answer verified against graph rows.</a:t>
+            </a:r>
+          </a:p>
+          <a:p>
+            <a:r>
+              <a:t>• 9 steps, 6,461 tokens. Stop reason sufficient_evidence.</a:t>
+            </a:r>
           </a:p>
         </p:txBody>
       </p:sp>

</xml_diff>

<commit_message>
Deck notes: drop stray separators
Co-Authored-By: Claude Opus 5.5 <noreply@anthropic.com>
Claude-Session: https://claude.ai/code/session_01TceV3SW8zHDtYbysNyQAPx
</commit_message>
<xml_diff>
--- a/submission/Agentic-GraphRAG-Application-Walkthrough.pptx
+++ b/submission/Agentic-GraphRAG-Application-Walkthrough.pptx
@@ -2468,11 +2468,6 @@
               <a:t>• Invite questions.</a:t>
             </a:r>
           </a:p>
-          <a:p>
-            <a:r>
-              <a:t>---</a:t>
-            </a:r>
-          </a:p>
           <a:p/>
           <a:p>
             <a:r>

</xml_diff>

<commit_message>
Remove presenter-only notes from the submission
Co-Authored-By: Claude Opus 5.5 <noreply@anthropic.com>
Claude-Session: https://claude.ai/code/session_01TceV3SW8zHDtYbysNyQAPx
</commit_message>
<xml_diff>
--- a/submission/Agentic-GraphRAG-Application-Walkthrough.pptx
+++ b/submission/Agentic-GraphRAG-Application-Walkthrough.pptx
@@ -2468,132 +2468,6 @@
               <a:t>• Invite questions.</a:t>
             </a:r>
           </a:p>
-          <a:p/>
-          <a:p>
-            <a:r>
-              <a:t>Q&amp;A</a:t>
-            </a:r>
-          </a:p>
-          <a:p>
-            <a:r>
-              <a:t>Q: Is the comparison fair?</a:t>
-            </a:r>
-          </a:p>
-          <a:p>
-            <a:r>
-              <a:t>A: Same LLM, temp 0, byte-identical answer prompt, same scorer, same graph and embeddings. GraphRAG gets every graph fix. Only the method differs.</a:t>
-            </a:r>
-          </a:p>
-          <a:p>
-            <a:r>
-              <a:t>Q: Did you tune on the public set?</a:t>
-            </a:r>
-          </a:p>
-          <a:p>
-            <a:r>
-              <a:t>A: No prompt tuned. Each gain fixed a named root cause found in traces. RAG (untouched) stayed 0.59–0.62 across r1–r5. Tests block templates and question-type reads.</a:t>
-            </a:r>
-          </a:p>
-          <a:p>
-            <a:r>
-              <a:t>Q: Why is Agentic grounding (0.79) below RAG (0.93)?</a:t>
-            </a:r>
-          </a:p>
-          <a:p>
-            <a:r>
-              <a:t>A: Grounding = answer names found in the cited text. Count answers cite count rows with no prose. Separate graph-support check: 90/100 answers supported.</a:t>
-            </a:r>
-          </a:p>
-          <a:p>
-            <a:r>
-              <a:t>Q: Why is GraphRAG worse than RAG on temporal/multi-hop?</a:t>
-            </a:r>
-          </a:p>
-          <a:p>
-            <a:r>
-              <a:t>A: One query, no loop: cannot chain hops or recover from a weak first query. That gap is the loop's value.</a:t>
-            </a:r>
-          </a:p>
-          <a:p>
-            <a:r>
-              <a:t>Q: Why is the agent cheaper than RAG?</a:t>
-            </a:r>
-          </a:p>
-          <a:p>
-            <a:r>
-              <a:t>A: 62% of questions take the direct route (median 1,924 tokens). RAG always sends 10 chunks (~6.5k tokens).</a:t>
-            </a:r>
-          </a:p>
-          <a:p>
-            <a:r>
-              <a:t>Q: When is the agent not worth it?</a:t>
-            </a:r>
-          </a:p>
-          <a:p>
-            <a:r>
-              <a:t>A: Single-fact lookups and dates: RAG is already exact. The router keeps those cheap (0.30× tokens).</a:t>
-            </a:r>
-          </a:p>
-          <a:p>
-            <a:r>
-              <a:t>Q: What did the agent get wrong?</a:t>
-            </a:r>
-          </a:p>
-          <a:p>
-            <a:r>
-              <a:t>A: 2/100 in r5. pub-067: venue parsed into the event slot (fixed after r5, verified live). pub-088: model copied an evidence field (answer now cleaned; residual is intent-parse variance).</a:t>
-            </a:r>
-          </a:p>
-          <a:p>
-            <a:r>
-              <a:t>Q: Hidden set?</a:t>
-            </a:r>
-          </a:p>
-          <a:p>
-            <a:r>
-              <a:t>A: 50 questions, run once, 0 errors in 150 answers. Raw outputs and traces in submission/. No gold, so cost/routing/grounding only. Produced by the pre-final-round system (decision recorded).</a:t>
-            </a:r>
-          </a:p>
-          <a:p>
-            <a:r>
-              <a:t>Q: How do you handle LLM/graph failures?</a:t>
-            </a:r>
-          </a:p>
-          <a:p>
-            <a:r>
-              <a:t>A: Retries with backoff. Failures recorded on the trace step and as errors; a resumed batch re-runs only failed questions. Never turned into "no evidence".</a:t>
-            </a:r>
-          </a:p>
-          <a:p>
-            <a:r>
-              <a:t>Q: Why TigerGraph?</a:t>
-            </a:r>
-          </a:p>
-          <a:p>
-            <a:r>
-              <a:t>A: Typed multi-hop traversal (venue → event → edition) plus native vector search (HNSW) in one store. Installed GSQL queries Q1–Q5 keep tool calls deterministic and 0-token.</a:t>
-            </a:r>
-          </a:p>
-          <a:p>
-            <a:r>
-              <a:t>Q: How does it scale to new data?</a:t>
-            </a:r>
-          </a:p>
-          <a:p>
-            <a:r>
-              <a:t>A: Upload any JSONL corpus. Datasets are tracked per id, rebuilt independently. Embedding models switch per graph.</a:t>
-            </a:r>
-          </a:p>
-          <a:p>
-            <a:r>
-              <a:t>Q: Round 2 readiness?</a:t>
-            </a:r>
-          </a:p>
-          <a:p>
-            <a:r>
-              <a:t>A: First step done: answer verification flags infobox-vs-prose figure conflicts. Next: versioned facts, supersession, source authority.</a:t>
-            </a:r>
-          </a:p>
         </p:txBody>
       </p:sp>
       <p:sp>

</xml_diff>